<commit_message>
updates after testing phase
</commit_message>
<xml_diff>
--- a/static/thursday/overview_binarylabs.pptx
+++ b/static/thursday/overview_binarylabs.pptx
@@ -197,7 +197,7 @@
           <a:p>
             <a:fld id="{CD69D2CB-1D3A-B541-8456-75685EEE6F33}" type="datetimeFigureOut">
               <a:rPr lang="en-NL" smtClean="0"/>
-              <a:t>18/05/2026</a:t>
+              <a:t>05/06/2026</a:t>
             </a:fld>
             <a:endParaRPr lang="en-NL"/>
           </a:p>
@@ -680,7 +680,7 @@
           <a:p>
             <a:fld id="{F2868297-12AD-5845-BBB0-1931D1C3A5BA}" type="datetimeFigureOut">
               <a:rPr lang="en-NL" smtClean="0"/>
-              <a:t>18/05/2026</a:t>
+              <a:t>05/06/2026</a:t>
             </a:fld>
             <a:endParaRPr lang="en-NL"/>
           </a:p>
@@ -850,7 +850,7 @@
           <a:p>
             <a:fld id="{F2868297-12AD-5845-BBB0-1931D1C3A5BA}" type="datetimeFigureOut">
               <a:rPr lang="en-NL" smtClean="0"/>
-              <a:t>18/05/2026</a:t>
+              <a:t>05/06/2026</a:t>
             </a:fld>
             <a:endParaRPr lang="en-NL"/>
           </a:p>
@@ -1030,7 +1030,7 @@
           <a:p>
             <a:fld id="{F2868297-12AD-5845-BBB0-1931D1C3A5BA}" type="datetimeFigureOut">
               <a:rPr lang="en-NL" smtClean="0"/>
-              <a:t>18/05/2026</a:t>
+              <a:t>05/06/2026</a:t>
             </a:fld>
             <a:endParaRPr lang="en-NL"/>
           </a:p>
@@ -1200,7 +1200,7 @@
           <a:p>
             <a:fld id="{F2868297-12AD-5845-BBB0-1931D1C3A5BA}" type="datetimeFigureOut">
               <a:rPr lang="en-NL" smtClean="0"/>
-              <a:t>18/05/2026</a:t>
+              <a:t>05/06/2026</a:t>
             </a:fld>
             <a:endParaRPr lang="en-NL"/>
           </a:p>
@@ -1446,7 +1446,7 @@
           <a:p>
             <a:fld id="{F2868297-12AD-5845-BBB0-1931D1C3A5BA}" type="datetimeFigureOut">
               <a:rPr lang="en-NL" smtClean="0"/>
-              <a:t>18/05/2026</a:t>
+              <a:t>05/06/2026</a:t>
             </a:fld>
             <a:endParaRPr lang="en-NL"/>
           </a:p>
@@ -1678,7 +1678,7 @@
           <a:p>
             <a:fld id="{F2868297-12AD-5845-BBB0-1931D1C3A5BA}" type="datetimeFigureOut">
               <a:rPr lang="en-NL" smtClean="0"/>
-              <a:t>18/05/2026</a:t>
+              <a:t>05/06/2026</a:t>
             </a:fld>
             <a:endParaRPr lang="en-NL"/>
           </a:p>
@@ -2045,7 +2045,7 @@
           <a:p>
             <a:fld id="{F2868297-12AD-5845-BBB0-1931D1C3A5BA}" type="datetimeFigureOut">
               <a:rPr lang="en-NL" smtClean="0"/>
-              <a:t>18/05/2026</a:t>
+              <a:t>05/06/2026</a:t>
             </a:fld>
             <a:endParaRPr lang="en-NL"/>
           </a:p>
@@ -2163,7 +2163,7 @@
           <a:p>
             <a:fld id="{F2868297-12AD-5845-BBB0-1931D1C3A5BA}" type="datetimeFigureOut">
               <a:rPr lang="en-NL" smtClean="0"/>
-              <a:t>18/05/2026</a:t>
+              <a:t>05/06/2026</a:t>
             </a:fld>
             <a:endParaRPr lang="en-NL"/>
           </a:p>
@@ -2258,7 +2258,7 @@
           <a:p>
             <a:fld id="{F2868297-12AD-5845-BBB0-1931D1C3A5BA}" type="datetimeFigureOut">
               <a:rPr lang="en-NL" smtClean="0"/>
-              <a:t>18/05/2026</a:t>
+              <a:t>05/06/2026</a:t>
             </a:fld>
             <a:endParaRPr lang="en-NL"/>
           </a:p>
@@ -2535,7 +2535,7 @@
           <a:p>
             <a:fld id="{F2868297-12AD-5845-BBB0-1931D1C3A5BA}" type="datetimeFigureOut">
               <a:rPr lang="en-NL" smtClean="0"/>
-              <a:t>18/05/2026</a:t>
+              <a:t>05/06/2026</a:t>
             </a:fld>
             <a:endParaRPr lang="en-NL"/>
           </a:p>
@@ -2792,7 +2792,7 @@
           <a:p>
             <a:fld id="{F2868297-12AD-5845-BBB0-1931D1C3A5BA}" type="datetimeFigureOut">
               <a:rPr lang="en-NL" smtClean="0"/>
-              <a:t>18/05/2026</a:t>
+              <a:t>05/06/2026</a:t>
             </a:fld>
             <a:endParaRPr lang="en-NL"/>
           </a:p>
@@ -3005,7 +3005,7 @@
           <a:p>
             <a:fld id="{F2868297-12AD-5845-BBB0-1931D1C3A5BA}" type="datetimeFigureOut">
               <a:rPr lang="en-NL" smtClean="0"/>
-              <a:t>18/05/2026</a:t>
+              <a:t>05/06/2026</a:t>
             </a:fld>
             <a:endParaRPr lang="en-NL"/>
           </a:p>
@@ -3412,10 +3412,10 @@
       </p:grpSpPr>
       <p:grpSp>
         <p:nvGrpSpPr>
-          <p:cNvPr id="31" name="Group 30">
+          <p:cNvPr id="4" name="Group 3">
             <a:extLst>
               <a:ext uri="{FF2B5EF4-FFF2-40B4-BE49-F238E27FC236}">
-                <a16:creationId xmlns:a16="http://schemas.microsoft.com/office/drawing/2014/main" id="{1857A27F-5305-C958-EE08-3FB2DBE41AE1}"/>
+                <a16:creationId xmlns:a16="http://schemas.microsoft.com/office/drawing/2014/main" id="{53E84719-DA73-E069-5845-2B5B31381CC5}"/>
               </a:ext>
             </a:extLst>
           </p:cNvPr>
@@ -3424,12 +3424,64 @@
         </p:nvGrpSpPr>
         <p:grpSpPr>
           <a:xfrm>
-            <a:off x="838160" y="2225979"/>
-            <a:ext cx="5947569" cy="6749303"/>
-            <a:chOff x="838160" y="2225979"/>
-            <a:chExt cx="5947569" cy="6749303"/>
+            <a:off x="601490" y="2317021"/>
+            <a:ext cx="6305938" cy="7327557"/>
+            <a:chOff x="675630" y="2144027"/>
+            <a:chExt cx="6305938" cy="7327557"/>
           </a:xfrm>
         </p:grpSpPr>
+        <p:sp>
+          <p:nvSpPr>
+            <p:cNvPr id="3" name="Rounded Rectangle 2">
+              <a:extLst>
+                <a:ext uri="{FF2B5EF4-FFF2-40B4-BE49-F238E27FC236}">
+                  <a16:creationId xmlns:a16="http://schemas.microsoft.com/office/drawing/2014/main" id="{FF21BBE6-7C30-DF68-97DB-948D393DBB50}"/>
+                </a:ext>
+              </a:extLst>
+            </p:cNvPr>
+            <p:cNvSpPr/>
+            <p:nvPr/>
+          </p:nvSpPr>
+          <p:spPr>
+            <a:xfrm>
+              <a:off x="675630" y="2144027"/>
+              <a:ext cx="6305938" cy="7327557"/>
+            </a:xfrm>
+            <a:prstGeom prst="roundRect">
+              <a:avLst/>
+            </a:prstGeom>
+            <a:solidFill>
+              <a:srgbClr val="FFFFFF"/>
+            </a:solidFill>
+            <a:ln>
+              <a:noFill/>
+            </a:ln>
+          </p:spPr>
+          <p:style>
+            <a:lnRef idx="2">
+              <a:schemeClr val="accent1">
+                <a:shade val="15000"/>
+              </a:schemeClr>
+            </a:lnRef>
+            <a:fillRef idx="1">
+              <a:schemeClr val="accent1"/>
+            </a:fillRef>
+            <a:effectRef idx="0">
+              <a:schemeClr val="accent1"/>
+            </a:effectRef>
+            <a:fontRef idx="minor">
+              <a:schemeClr val="lt1"/>
+            </a:fontRef>
+          </p:style>
+          <p:txBody>
+            <a:bodyPr rtlCol="0" anchor="ctr"/>
+            <a:lstStyle/>
+            <a:p>
+              <a:pPr algn="ctr"/>
+              <a:endParaRPr lang="en-NL"/>
+            </a:p>
+          </p:txBody>
+        </p:sp>
         <p:grpSp>
           <p:nvGrpSpPr>
             <p:cNvPr id="12" name="Group 11">

</xml_diff>